<commit_message>
Deepen Hebrew deck content to match English; re-verify English pptx rebuild
- Ports the same content-depth pass to build_deck.py (Hebrew): a fuller
  "What is GitHub Spec Kit / why it exists" slide, terse bullets expanded
  into full sentences, and richer instructor notes across the deck.
- Re-renders build_deck_en.py's output pptx, which had drifted from its
  final source after a slide-19 layout fix (the earlier committed pptx
  binary predated that fix even though the .py was already correct).
</commit_message>
<xml_diff>
--- a/presentation/speckit-workshop-draft.pptx
+++ b/presentation/speckit-workshop-draft.pptx
@@ -529,7 +529,7 @@
           <a:lstStyle/>
           <a:p>
             <a:r>
-              <a:t>לפתוח בשאלה לקהל: מי כבר ביקש מ-AI לכתוב קוד ישירות מפרומפט?</a:t>
+              <a:t>לפתוח בהצבעה: מי כבר ביקש פעם מסוכן AI לקוד 'סתם לבנות X' ממשפט אחד? כמעט כולם. ההרצאה הזו עוסקת במה שקורה אחר כך -- ובדוגמה אמיתית וקונקרטית ממערכות משובצות (מוניטור טמפרטורה על לוח Heltec מבוסס ESP32) שנעקוב אחריה מפרומפט מעורפל ועד קושחה בדוקה, עובדת, שאומתה פיזית. לא נדרש ידע קודם ב-Spec Kit, במערכות משובצות, ואפילו לא בסוכני AI.</a:t>
             </a:r>
           </a:p>
         </p:txBody>
@@ -599,7 +599,7 @@
           <a:lstStyle/>
           <a:p>
             <a:r>
-              <a:t>לא לצלול לתחביר הפקודות -- המטרה היא המודל המנטלי.</a:t>
+              <a:t>לא לצלול עדיין לתחביר הפקודות -- המטרה כאן היא רק המודל המנטלי של הצינור: constitution (כללי פרויקט כלל-ארגוניים, נכתבים פעם אחת) -&gt; specify (מה בונים) -&gt; clarify (פותרים את החלקים המעורפלים) -&gt; plan (הגישה הטכנית) -&gt; tasks (פירוק התוכנית לצעדים מסודרים וניתנים לבדיקה) -&gt; analyze (בדיקה אוטומטית של spec/plan/tasks לסתירות) -&gt; implement (הסוכן כותב את הקוד). כל שלב מייצר קובץ אמיתי ברפוזיטורי, שזה הנושא של השקף הבא. כבר הצגנו בקצרה *למה* כל שלב קיים בשקף 7 -- זה השקף שמראה את הסדר שבו הם רצים.</a:t>
             </a:r>
           </a:p>
         </p:txBody>
@@ -667,7 +667,11 @@
         <p:txBody>
           <a:bodyPr/>
           <a:lstStyle/>
-          <a:p/>
+          <a:p>
+            <a:r>
+              <a:t>זה רגע טוב לפתוח בפועל את specs/001-heltec-monitor/spec.md בעורך, ולו רק לגלול בו -- לראות קובץ Markdown אמיתי וקריא (לא קוד, לא JSON) בדרך כלל מפשיט את כל הרעיון לקהל שאין לו רקע קודם.</a:t>
+            </a:r>
+          </a:p>
         </p:txBody>
       </p:sp>
       <p:sp>
@@ -735,7 +739,7 @@
           <a:lstStyle/>
           <a:p>
             <a:r>
-              <a:t>'Spec Kit הוא לא סוכן הקידוד. Claude Code או Codex מבצעים את העבודה. ה-IDE הוא סביבת העבודה האנושית.'</a:t>
+              <a:t>חשוב לומר את זה במפורש, זו נקודת הבלבול הנפוצה ביותר למתחילים: Spec Kit הוא לא סוכן קידוד והוא לא כותב קוד. Claude Code או Codex הם הסוכנים שבפועל קוראים את קבצי spec/plan/tasks וכותבים את הקושחה. ה-IDE (VS Code, CLion/JetBrains) הוא רק סביבת העבודה של האדם לקריאה ועריכה של קבצים לצד הסוכן. כלומר המבנה הוא: IDE (אדם) + סוכן קידוד (מבצע את העבודה) + Spec Kit (התהליך המובנה שהסוכן פועל לפיו) -- שלוש שכבות נפרדות, כל אחת ניתנת להחלפה, לא מוצר אחד.</a:t>
             </a:r>
           </a:p>
         </p:txBody>
@@ -805,7 +809,7 @@
           <a:lstStyle/>
           <a:p>
             <a:r>
-              <a:t>screenshots #6-7.</a:t>
+              <a:t>כאן נכנסים screenshots #6-7 מהצ'קליסט. אם יש טרמינל חי זמין, שווה להריץ בפועל /speckit-specify בסוכן אחד ו-$speckit-specify בשני נגד הריפו הזה, כדי להראות שזה אותו skill בבסיס, רק תחביר הפעלה שונה לכל סוכן.</a:t>
             </a:r>
           </a:p>
         </p:txBody>
@@ -873,7 +877,11 @@
         <p:txBody>
           <a:bodyPr/>
           <a:lstStyle/>
-          <a:p/>
+          <a:p>
+            <a:r>
+              <a:t>לשמור על זה קצר -- הנקודה היא שהעורך הוא הבחירה הכי פחות חשובה בכל התהליך הזה. לא כדאי להיגרר לוויכוח על extensions -- שניים זו כל הרשימה.</a:t>
+            </a:r>
+          </a:p>
         </p:txBody>
       </p:sp>
       <p:sp>
@@ -939,7 +947,11 @@
         <p:txBody>
           <a:bodyPr/>
           <a:lstStyle/>
-          <a:p/>
+          <a:p>
+            <a:r>
+              <a:t>traceability פירושו: אפשר להצביע על הרגע והסיבה המדויקים שדרישה הוחלטה? repeatability פירושו: אם נותנים את אותו המפרט לסוכן אחר, או מריצים את התהליך שוב, האם מגיעים לתוצאה דומה? שניהם נמוכים באופן טבעי בפרומפט אד-הוק בודד כי שום דבר לא נכתב, וגבוהים יותר באופן טבעי עם Spec Kit כי הדרישות הן קבצים, לא זיכרון.</a:t>
+            </a:r>
+          </a:p>
         </p:txBody>
       </p:sp>
       <p:sp>
@@ -1007,7 +1019,7 @@
           <a:lstStyle/>
           <a:p>
             <a:r>
-              <a:t>לא סקירת frameworks -- זו לא המטרה של הסדנה.</a:t>
+              <a:t>לא סקירת frameworks -- לא להשקיע כאן יותר מדקה, זו לא המטרה של הסדנה. המסר היחיד ששווה להעביר: זה ספקטרום (בלי תהליך -&gt; Spec Kit -&gt; frameworks כבדים יותר), וכמות התהליך הנכונה תלויה בגודל הפרויקט והצוות.</a:t>
             </a:r>
           </a:p>
         </p:txBody>
@@ -1075,7 +1087,11 @@
         <p:txBody>
           <a:bodyPr/>
           <a:lstStyle/>
-          <a:p/>
+          <a:p>
+            <a:r>
+              <a:t>השקף הזה קיים כדי לבסס אמינות חומרה אמיתית לפני שמשווים בין שתי גישות הבנייה -- מכאן והלאה הכול מבוסס על לוח פיזי אמיתי, לא דוגמת צעצוע.</a:t>
+            </a:r>
+          </a:p>
         </p:txBody>
       </p:sp>
       <p:sp>
@@ -1143,7 +1159,7 @@
           <a:lstStyle/>
           <a:p>
             <a:r>
-              <a:t>ויזואל: examples/prompt-only/naive_monitor.ino</a:t>
+              <a:t>ויזואל: examples/prompt-only/naive_monitor.ino. אם הוא פתוח, כדאי לגלול לבדיקת הסף ולהצביע שיש בדיוק השוואה אחת (value &gt; 30) בלי תנאי שני לכיבוי האזהרה -- ה'ענף else' החסר הזה הוא כל סיפור ההיסטרזיס, שמגיע בפירוט בשקף 20.</a:t>
             </a:r>
           </a:p>
         </p:txBody>
@@ -1211,7 +1227,11 @@
         <p:txBody>
           <a:bodyPr/>
           <a:lstStyle/>
-          <a:p/>
+          <a:p>
+            <a:r>
+              <a:t>זה התמליל האמיתי של clarify מהפרויקט הזה, לא הדמיה. שווה להצביע שאלה בדיוק סוג השאלות שמבקר אנושי זהיר היה שואל -- הסוכן פשוט שואל אותן מוקדם יותר, לפני כתיבת קוד, ומתעד את התשובות כדי שלעולם לא יאבדו.</a:t>
+            </a:r>
+          </a:p>
         </p:txBody>
       </p:sp>
       <p:sp>
@@ -1279,7 +1299,7 @@
           <a:lstStyle/>
           <a:p>
             <a:r>
-              <a:t>שאלה פתוחה לקהל -- לתת רגע לחשוב לפני שממשיכים.</a:t>
+              <a:t>לקרוא את הפרומפט בקול, לאט. הוא נשמע שלם -- יש בו חיישן, מסך, אזהרה. זו בדיוק המלכודת: הוא נשמע כמו מפרט אבל הוא לא. לתת לקהל רגע אמיתי של שקט לפני שממשיכים לשקף 3, שם נפרק את כל מה שהמשפט הזה השאיר בשקט לא מוחלט.</a:t>
             </a:r>
           </a:p>
         </p:txBody>
@@ -1349,7 +1369,7 @@
           <a:lstStyle/>
           <a:p>
             <a:r>
-              <a:t>זו לא בעיית תכנות. זו החלטת מוצר שהיתה חייבת להתקבל *לפני* כתיבת קוד.</a:t>
+              <a:t>לעבור על הדיאגרמה משמאל לימין: הטמפרטורה חוצה את ה-30°C, ה-WARNING נדלק. בלי רצועת סבילות, ברגע שהטמפרטורה יורדת חזרה ל-29.9°C המסך היה קופץ מיד חזרה ל-OK, ואז חזרה ל-WARNING בתנודה הקטנה הבאה -- הבהוב על כל חצייה של מספר בודד. הרצועה (כאן, 28-30°C) אומרת שברגע שה-WARNING דלוק, הוא *נשאר* דלוק בכל מקום בתוך הרצועה, ונכבה רק כשהטמפרטורה יורדת מתחת לקצה התחתון (28°C). זו לא בעיית תכנות לניפוי -- זו החלטת מוצר (כמה סבילות מקובלת) שהיתה חייבת להתקבל לפני שנכתבה שורה אחת של מכונת המצבים, ובדיוק זה סוג ההחלטה ששלב ה-clarify קיים כדי לחשוף.</a:t>
             </a:r>
           </a:p>
         </p:txBody>
@@ -1419,7 +1439,7 @@
           <a:lstStyle/>
           <a:p>
             <a:r>
-              <a:t>screenshots #10-11 (plan.md, tasks.md) אם רוצים להראות גם את הקבצים עצמם.</a:t>
+              <a:t>plan הופך את הדרישות שכבר הובהרו לגישה טכנית קונקרטית: איזה לוח, אילו ספריות, ובאופן קריטי, ארכיטקטורה שמפוצלת לשלושה חלקים נפרדים -- מתאם חיישן, לוגיקת החלטה טהורה ללא שום תלות בחומרה, ורכיב דיווח למסך OLED ול-Serial. tasks לאחר מכן מפרק את התוכנית לצעדים קטנים, מסודרים, וניתנים לבדיקה, שסוכן (או אדם) יכול לבצע אחד אחד. הפיצול הארכיטקטוני שמוצג כאן הוא מה שמאפשר את הבדיקה האוטומטית בשקף הבא: מכיוון שלוגיקת ההחלטה לא נוגעת בחומרה בכלל, אפשר לבדוק אותה על מחשב נייד בלי לוח Heltec מחובר בכלל. אם רוצים להראות גם את הקבצים עצמם, screenshots #10-11 בצ'קליסט הם plan.md ו-tasks.md עצמם.</a:t>
             </a:r>
           </a:p>
         </p:txBody>
@@ -1489,7 +1509,7 @@
           <a:lstStyle/>
           <a:p>
             <a:r>
-              <a:t>שקף חשוב ביותר -- לא להעביר במהירות. זו לא דוגמה מומצאת לצורך ההרצאה -- זה קרה ממש בבניית הפרויקט הזה. אפשר להראות live: git show b91cd94 -- specs/001-heltec-monitor/spec.md</a:t>
+              <a:t>השקף החשוב ביותר בכל ההרצאה -- לא להעביר במהירות. לעבור על כל אחת מחמש התיבות: (1) בשלב clarify, הוחלט שהאזהרה צריכה להישאר דלוקה בתוך רצועת ההיסטרזיס; (2) אבל קריטריון הצלחה נפרד (SC-004), שנכתב קודם, עדיין תיאר את ההתנהגות הפשוטה יותר של דלוק/כבוי -- אף אחד לא שם לב שהשניים כבר לא תואמים; (3) /speckit-analyze, שבודק אוטומטית spec/plan/tasks אחד מול השני, תפס את הסתירה הזו; (4) המפרט תוקן במקום; (5) המימוש התחיל רק אחרי שהמסמכים הסכימו ביניהם. זו לא דוגמה מומצאת לצורך ההרצאה -- זה קרה ממש בבניית הפרויקט הזה, והתיעוד המלא שמור ב-specs/001-heltec-monitor/analysis-report.md. אם יש טרמינל, אפשר להראות live: git show b91cd94 -- specs/001-heltec-monitor/spec.md משחזר את ה-diff המדויק.</a:t>
             </a:r>
           </a:p>
         </p:txBody>
@@ -1559,7 +1579,7 @@
           <a:lstStyle/>
           <a:p>
             <a:r>
-              <a:t>ההוכחה הכי חזקה לערך של Spec Kit בכל ההרצאה.</a:t>
+              <a:t>ההוכחה הכי חזקה לערך של Spec Kit בכל ההרצאה -- אם הקהל זוכר רגע קונקרטי אחד מהסדנה, שיהיה זה. התמונה למטה היא ה-diff האמיתי: הניסוח הישן של SC-004 משמאל/אדום, הניסוח המתוקן מימין/ירוק, מראה את קריטריון ההצלחה מעודכן כדי להתאים להחלטת ההיסטרזיס מ-clarify. חשוב להדגיש: לא נכתב שום קוד עדיין כשזה נתפס -- לתקן סתירה בין שני מסמכי Markdown עולה כמה שניות; לתקן את אותה סתירה אחרי שכבר הפכה לשתי התנהגויות קושחה סותרות היה עולה הרבה יותר, ואולי בכלל לא היה נתפס בלי בדיקת חומרה שמפעילה בדיוק את מקרה הקצה הזה.</a:t>
             </a:r>
           </a:p>
         </p:txBody>
@@ -1627,7 +1647,11 @@
         <p:txBody>
           <a:bodyPr/>
           <a:lstStyle/>
-          <a:p/>
+          <a:p>
+            <a:r>
+              <a:t>implement הוא השלב שסוף-סוף כותב את קוד הקושחה בפועל, לפי plan.md ו-tasks.md, בסדר. מכיוון שלוגיקת ההחלטה (monitor_logic, מוצגת למעלה) תוכננה ללא שום תלות בחומרה עוד בשלב plan, אפשר להריץ עליה חבילת בדיקות אוטומטית ישירות על מחשב נייד -- בלי לוח Heltec, בלי כבל סריאלי, בלי שום דבר פיזי. הפאנל בפינה השמאלית-תחתונה הוא הפלט האמיתי, ללא עריכה, של הרצת הבדיקות הזו: 11 מתוך 11 עברו. זו הסיבה שכבר יש לנו ביטחון גבוה בלוגיקת ההחלטה עצמה עוד לפני שנגענו בחומרה אמיתית -- מה שעדיין לא מאומת זה רק החיווט הפיזי, החיישן והמסך, ובדיוק זה הנושא של שני השקפים הבאים.</a:t>
+            </a:r>
+          </a:p>
         </p:txBody>
       </p:sp>
       <p:sp>
@@ -1971,7 +1995,7 @@
           <a:lstStyle/>
           <a:p>
             <a:r>
-              <a:t>אפשר להראות כאן את examples/prompt-only/naive_monitor.ino בקצרה.</a:t>
+              <a:t>כל שורה כאן היא החלטה אמיתית, ופרומפט לא מפורט לא מבטל את ההחלטה -- הוא רק מעביר אותה אל תוך הראש של המודל, איפה שאי אפשר לראות אותה, לבדוק אותה או להסכים איתה. אפשר להראות כאן את examples/prompt-only/naive_monitor.ino כדי להוכיח שאלה לא שאלות תיאורטיות: להצביע אילו שורות בקוד שנוצר בפועל ענו בשקט על כל אחת מהשאלות למעלה.</a:t>
             </a:r>
           </a:p>
         </p:txBody>
@@ -2041,7 +2065,7 @@
           <a:lstStyle/>
           <a:p>
             <a:r>
-              <a:t>זה המשפט שהקהל צריך לזכור מהסדנה כולה. לעצור רגע אחרי השקף הזה.</a:t>
+              <a:t>זה המשפט שהקהל צריך לזכור מהסדנה כולה -- לעצור רגע אחרי שקוראים אותו בקול. מודלים מודרניים כבר טובים מספיק בכתיבת קוד; זה כבר לא צוואר הבקבוק. צוואר הבקבוק זז מעלה בזרם, לשלב ההחלטה מה בדיוק הקוד אמור לעשות. Spec Kit, שנציג בעוד רגע, הוא כלי שהופך את שלב קבלת ההחלטות הזה למפורש ומובנה במקום מרומז ומדולג.</a:t>
             </a:r>
           </a:p>
         </p:txBody>
@@ -2111,7 +2135,7 @@
           <a:lstStyle/>
           <a:p>
             <a:r>
-              <a:t>להתמקד בחצי העליון של הדיאגרמה כרגע. כל 'תיקון' הוא החלטת מוצר שמתקבלת אחרי שכבר יש קוד שסותר אותה.</a:t>
+              <a:t>להתמקד רק בחצי העליון של הדיאגרמה כרגע (נחזור לחצי התחתון בשקף הבא). זו הלולאה הרגילה כשמדלגים על מפרט: פרומפט -&gt; קוד -&gt; שמים לב שמשהו לא בסדר -- שולחים פרומפט המשך לתיקון -&gt; התיקון חושף או שובר משהו אחר -&gt; חוזר חלילה. כל תיבת 'תיקון' היא החלטת מוצר שהתקבלה *אחרי* שכבר היה קוד שסותר אותה -- וזה הזמן היקר ביותר האפשרי לקבל את ההחלטה הזו, כי כבר יש קוד ואולי משתמש שתלוי בהתנהגות הלא נכונה.</a:t>
             </a:r>
           </a:p>
         </p:txBody>
@@ -2181,7 +2205,7 @@
           <a:lstStyle/>
           <a:p>
             <a:r>
-              <a:t>עכשיו להתמקד בחצי התחתון. ההבדל הוא לא 'יותר בירוקרטיה' -- זה להזיז את ההחלטות למקום שבו הן זולות לקבל.</a:t>
+              <a:t>עכשיו להצביע על החצי התחתון של אותה דיאגרמה. ההבדל הוא לא 'יותר ניירת' -- אותן החלטות בדיוק (איזה חיישן, מה הסף, מה קורה בתקלה) מתקבלות פעם אחת, במכוון, בשלב הבהרה קצר, לפני שיש קוד בכלל -- במקום אחת אחת, בטעות, אחרי שכבר יש קוד שצריך לפרק. אותו מספר החלטות בסך הכול; מה שמשתנה הוא רק *מתי* הן מתקבלות, והתזמון הזה הוא כל הצעת הערך של הסדנה הזו.</a:t>
             </a:r>
           </a:p>
         </p:txBody>
@@ -2321,7 +2345,7 @@
           <a:lstStyle/>
           <a:p>
             <a:r>
-              <a:t>screenshots #1-2 מהצ'קליסט.</a:t>
+              <a:t>זהו שקף העוגן של כל ההרצאה -- לא למהר. נקודות מפתח לומר בקול: (1) זה מ-GitHub, זה חינמי וקוד פתוח, זו לא הצעת מכירה למוצר בתשלום; (2) זה לא מחליף את Claude Code או Codex -- אלה הסוכנים שבפועל כותבים קוד, Spec Kit הוא שכבת התהליך המובנה מעליהם (יש לזה דיאגרמה משלה עוד שני שקפים קדימה); (3) הבעיה המניעה היא בדיוק מה ששקפים 2-4 הראו זה עתה: ייצור קוד מהיר חשף כמה מהעבודה האמיתית היא בעצם החלטה מה לבנות. אם יש זמן, כדאי להראות בקצרה את ה-GitHub repo האמיתי של Spec Kit ואת ה-README שלו (screenshots #1-2 בצ'קליסט) כדי שהקהל יראה שזה פרויקט אמיתי ופעיל, לא סקריפט חד-פעמי.</a:t>
             </a:r>
           </a:p>
         </p:txBody>
@@ -2391,7 +2415,7 @@
           <a:lstStyle/>
           <a:p>
             <a:r>
-              <a:t>זו התוצאה האמיתית מהאתחול של הריפו הזה עצמו.</a:t>
+              <a:t>השורה הראשונה מתקינה את כלי ה-CLI specify עצמו (הגדרה חד-פעמית, דרך כלי ה-uv של Python). השורה השנייה מריצה אותו בתוך תיקיית פרויקט קיימת ואומרת לה לאיזה סוכן להתחבר -- כאן, Claude Code. זה יוצר תיקיית .specify/ (תבניות, סקריפטים, חוקת הפרויקט) ותיקיית .claude/skills/ עם פקודות ה-/speckit-... . הפלט בטרמינל למטה הוא הפלט האמיתי, ללא עריכה, מהאתחול של הריפו הזה עצמו -- שום דבר כאן לא מבוים או מדומה.</a:t>
             </a:r>
           </a:p>
         </p:txBody>
@@ -5661,13 +5685,13 @@
               </a:spcAft>
             </a:pPr>
             <a:r>
-              <a:rPr sz="2200" b="0" i="0">
+              <a:rPr sz="2100" b="0" i="0">
                 <a:solidFill>
                   <a:srgbClr val="334155"/>
                 </a:solidFill>
                 <a:latin typeface="Arial"/>
               </a:rPr>
-              <a:t>לא שיחת צ'אט שנעלמת</a:t>
+              <a:t>כל שלב כותב קבצי Markdown רגילים לתוך הרפוזיטורי -- הם נשמרים ב-git כמו כל קובץ מקור אחר.</a:t>
             </a:r>
           </a:p>
           <a:p>
@@ -5677,13 +5701,29 @@
               </a:spcAft>
             </a:pPr>
             <a:r>
-              <a:rPr sz="2200" b="0" i="0">
+              <a:rPr sz="2100" b="0" i="0">
                 <a:solidFill>
                   <a:srgbClr val="334155"/>
                 </a:solidFill>
                 <a:latin typeface="Arial"/>
               </a:rPr>
-              <a:t>זה מה שמאפשר להחליף סוכן, לחזור אחרי חודש, ולראות בדיוק למה התקבלה כל החלטה</a:t>
+              <a:t>זה ההפך משיחת צ'אט, שחיה בכלי אחד, קל לאבד אותה, וקשה לאדם נוסף (או סוכן AI נוסף) להמשיך ממנה.</a:t>
+            </a:r>
+          </a:p>
+          <a:p>
+            <a:pPr algn="r" rtl="1">
+              <a:spcAft>
+                <a:spcPts val="1200"/>
+              </a:spcAft>
+            </a:pPr>
+            <a:r>
+              <a:rPr sz="2100" b="0" i="0">
+                <a:solidFill>
+                  <a:srgbClr val="334155"/>
+                </a:solidFill>
+                <a:latin typeface="Arial"/>
+              </a:rPr>
+              <a:t>התועלת המעשית: אפשר לסגור את הצ'אט, לעבור מ-Claude Code ל-Codex, או לחזור לפרויקט אחרי חודש, לפתוח את spec.md, ולראות בדיוק מה הוחלט ולמה -- בלי לשחזר את זה מהזיכרון.</a:t>
             </a:r>
           </a:p>
         </p:txBody>
@@ -5826,7 +5866,7 @@
         </p:nvSpPr>
         <p:spPr>
           <a:xfrm>
-            <a:off x="548640" y="1463040"/>
+            <a:off x="548640" y="1417320"/>
             <a:ext cx="11094415" cy="4206240"/>
           </a:xfrm>
           <a:prstGeom prst="rect">
@@ -5884,7 +5924,23 @@
                 </a:solidFill>
                 <a:latin typeface="Arial"/>
               </a:rPr>
-              <a:t>זה לא תיאוריה -- הריפו הזה מותקן עם שני האינטגרציות במקביל</a:t>
+              <a:t>אותה פקודה, אותם קבצים בבסיס, אותה תוצאה -- רק תחביר ההפעלה שונה, כי לכל סוכן יש מוסכמה משלו להפעלת פקודה מותאמת אישית.</a:t>
+            </a:r>
+          </a:p>
+          <a:p>
+            <a:pPr algn="r" rtl="1">
+              <a:spcAft>
+                <a:spcPts val="1200"/>
+              </a:spcAft>
+            </a:pPr>
+            <a:r>
+              <a:rPr sz="2000" b="0" i="0">
+                <a:solidFill>
+                  <a:srgbClr val="334155"/>
+                </a:solidFill>
+                <a:latin typeface="Arial"/>
+              </a:rPr>
+              <a:t>זו לא טענה תיאורטית -- הריפו הזה בדיוק מותקן עם שני האינטגרציות במקביל, וכל סוכן יכול להמשיך בדיוק מהמקום שהשני עצר בו.</a:t>
             </a:r>
           </a:p>
         </p:txBody>
@@ -5897,8 +5953,8 @@
         </p:nvSpPr>
         <p:spPr>
           <a:xfrm>
-            <a:off x="731520" y="3657600"/>
-            <a:ext cx="10728655" cy="2194560"/>
+            <a:off x="731520" y="3931920"/>
+            <a:ext cx="10728655" cy="1920240"/>
           </a:xfrm>
           <a:prstGeom prst="rect">
             <a:avLst/>
@@ -6035,13 +6091,13 @@
               </a:spcAft>
             </a:pPr>
             <a:r>
-              <a:rPr sz="2400" b="0" i="0">
+              <a:rPr sz="2100" b="0" i="0">
                 <a:solidFill>
                   <a:srgbClr val="334155"/>
                 </a:solidFill>
                 <a:latin typeface="Arial"/>
               </a:rPr>
-              <a:t>Extensions: PlatformIO IDE, C/C++ -- כל אחד עם סיבה, לא רשימה ארוכה</a:t>
+              <a:t>שני extensions עושים כאן את כל העבודה בפועל: PlatformIO IDE (בונה ומעלה את הקושחה, מנהל את שרשרת הכלים של ESP32) ו-C/C++ (הדגשת תחביר וניווט לקוד המקור של הקושחה).</a:t>
             </a:r>
           </a:p>
           <a:p>
@@ -6051,13 +6107,29 @@
               </a:spcAft>
             </a:pPr>
             <a:r>
-              <a:rPr sz="2400" b="0" i="0">
+              <a:rPr sz="2100" b="0" i="0">
                 <a:solidFill>
                   <a:srgbClr val="334155"/>
                 </a:solidFill>
                 <a:latin typeface="Arial"/>
               </a:rPr>
-              <a:t>JetBrains/CLion: אותם קבצים, טרמינל אחר</a:t>
+              <a:t>כל השאר בסדנה הזו -- הפקודות של Spec Kit, Claude Code, Codex -- עובד אותו דבר בלי קשר לעורך.</a:t>
+            </a:r>
+          </a:p>
+          <a:p>
+            <a:pPr algn="r" rtl="1">
+              <a:spcAft>
+                <a:spcPts val="1200"/>
+              </a:spcAft>
+            </a:pPr>
+            <a:r>
+              <a:rPr sz="2100" b="0" i="0">
+                <a:solidFill>
+                  <a:srgbClr val="334155"/>
+                </a:solidFill>
+                <a:latin typeface="Arial"/>
+              </a:rPr>
+              <a:t>אם משתמשים ב-JetBrains/CLion במקום: אותו רפוזיטורי, אותם קבצים, אותן פקודות Spec Kit, רק טרמינל שונה וסט קיצורי מקלדת שונה.</a:t>
             </a:r>
           </a:p>
         </p:txBody>
@@ -6123,7 +6195,7 @@
         </p:nvSpPr>
         <p:spPr>
           <a:xfrm>
-            <a:off x="731520" y="1097280"/>
+            <a:off x="731520" y="960120"/>
             <a:ext cx="10728655" cy="457200"/>
           </a:xfrm>
           <a:prstGeom prst="rect">
@@ -6132,19 +6204,20 @@
           <a:noFill/>
         </p:spPr>
         <p:txBody>
-          <a:bodyPr wrap="none">
+          <a:bodyPr wrap="square">
             <a:spAutoFit/>
           </a:bodyPr>
           <a:lstStyle/>
           <a:p>
             <a:pPr algn="r" rtl="1"/>
             <a:r>
-              <a:rPr b="1" sz="1800">
-                <a:solidFill>
-                  <a:srgbClr val="0F172A"/>
-                </a:solidFill>
-              </a:rPr>
-              <a:t>נושא        פרומפט ישיר              Spec Kit</a:t>
+              <a:rPr sz="1800" i="1">
+                <a:solidFill>
+                  <a:srgbClr val="334155"/>
+                </a:solidFill>
+                <a:latin typeface="Arial"/>
+              </a:rPr>
+              <a:t>אותו סוכן בבסיס, אותה חומרת יעד -- מה שמשתנה הוא איפה כל אחד מהדברים הבאים חי:</a:t>
             </a:r>
           </a:p>
         </p:txBody>
@@ -6406,13 +6479,13 @@
               </a:spcAft>
             </a:pPr>
             <a:r>
-              <a:rPr sz="2200" b="0" i="0">
+              <a:rPr sz="1900" b="0" i="0">
                 <a:solidFill>
                   <a:srgbClr val="334155"/>
                 </a:solidFill>
                 <a:latin typeface="Arial"/>
               </a:rPr>
-              <a:t>OpenSpec -- טריטוריה דומה, template/command set שונה</a:t>
+              <a:t>Spec Kit הוא לא הכלי היחיד בתחום הזה -- שווה לדעת שזו נקודה אחת על ספקטרום, לא האופציה היחידה.</a:t>
             </a:r>
           </a:p>
           <a:p>
@@ -6422,13 +6495,13 @@
               </a:spcAft>
             </a:pPr>
             <a:r>
-              <a:rPr sz="2200" b="0" i="0">
-                <a:solidFill>
-                  <a:srgbClr val="334155"/>
-                </a:solidFill>
-                <a:latin typeface="Arial"/>
-              </a:rPr>
-              <a:t>BMAD -- יותר roles ו-handoffs, יותר overhead</a:t>
+              <a:rPr sz="1900" b="1" i="0">
+                <a:solidFill>
+                  <a:srgbClr val="2563EB"/>
+                </a:solidFill>
+                <a:latin typeface="Arial"/>
+              </a:rPr>
+              <a:t>OpenSpec</a:t>
             </a:r>
           </a:p>
           <a:p>
@@ -6438,13 +6511,61 @@
               </a:spcAft>
             </a:pPr>
             <a:r>
-              <a:rPr sz="2200" b="0" i="0">
+              <a:rPr sz="1900" b="0" i="0">
                 <a:solidFill>
                   <a:srgbClr val="334155"/>
                 </a:solidFill>
                 <a:latin typeface="Arial"/>
               </a:rPr>
-              <a:t>Spec Kit נמצא בין פרומפט חופשי לתהליכי multi-agent כבדים</a:t>
+              <a:t>מכסה טריטוריה דומה -- לכתוב מפרט לפני קוד -- עם תבנית ומוסכמות פקודות משלו.</a:t>
+            </a:r>
+          </a:p>
+          <a:p>
+            <a:pPr algn="r" rtl="1">
+              <a:spcAft>
+                <a:spcPts val="1200"/>
+              </a:spcAft>
+            </a:pPr>
+            <a:r>
+              <a:rPr sz="1900" b="1" i="0">
+                <a:solidFill>
+                  <a:srgbClr val="D97706"/>
+                </a:solidFill>
+                <a:latin typeface="Arial"/>
+              </a:rPr>
+              <a:t>BMAD (Breakthrough Method for Agile AI-Driven Development)</a:t>
+            </a:r>
+          </a:p>
+          <a:p>
+            <a:pPr algn="r" rtl="1">
+              <a:spcAft>
+                <a:spcPts val="1200"/>
+              </a:spcAft>
+            </a:pPr>
+            <a:r>
+              <a:rPr sz="1900" b="0" i="0">
+                <a:solidFill>
+                  <a:srgbClr val="334155"/>
+                </a:solidFill>
+                <a:latin typeface="Arial"/>
+              </a:rPr>
+              <a:t>הולך צעד נוסף: מספר תפקידי AI מוגדרים (אנליסט, ארכיטקט, מפתח, QA) שמעבירים עבודה זה לזה, מה שמוסיף מבנה אמיתי אבל גם overhead אמיתי לפרויקט קטן.</a:t>
+            </a:r>
+          </a:p>
+          <a:p>
+            <a:pPr algn="r" rtl="1">
+              <a:spcAft>
+                <a:spcPts val="1200"/>
+              </a:spcAft>
+            </a:pPr>
+            <a:r>
+              <a:rPr sz="1900" b="1" i="0">
+                <a:solidFill>
+                  <a:srgbClr val="334155"/>
+                </a:solidFill>
+                <a:latin typeface="Arial"/>
+              </a:rPr>
+              <a:t>Spec Kit יושב בכוונה באמצע: יותר מבנה מפרומפט חשוף, הרבה פחות טקס מ-framework מרובה-תפקידים -- וזו הסיבה שהוא מתאים לדוגמת קושחה משובצת קטנה כמו זו.</a:t>
             </a:r>
           </a:p>
         </p:txBody>
@@ -6530,13 +6651,13 @@
               </a:spcAft>
             </a:pPr>
             <a:r>
-              <a:rPr sz="2200" b="0" i="0">
+              <a:rPr sz="2000" b="0" i="0">
                 <a:solidFill>
                   <a:srgbClr val="334155"/>
                 </a:solidFill>
                 <a:latin typeface="Arial"/>
               </a:rPr>
-              <a:t>Heltec WiFi Kit V3 (ESP32-S3), OLED מובנה, BME280 חיצוני</a:t>
+              <a:t>הלוח שאנחנו בונים עבורו בפועל: Heltec WiFi Kit V3, שהוא מיקרו-בקר ESP32-S3 עם מסך OLED קטן מובנה, ועוד חיישן BME280 חיצוני (טמפרטורה/לחות/לחץ אוויר) מחווט אליו ב-I2C.</a:t>
             </a:r>
           </a:p>
           <a:p>
@@ -6546,13 +6667,13 @@
               </a:spcAft>
             </a:pPr>
             <a:r>
-              <a:rPr sz="2200" b="1" i="0">
+              <a:rPr sz="2000" b="1" i="0">
                 <a:solidFill>
                   <a:srgbClr val="B91C1C"/>
                 </a:solidFill>
                 <a:latin typeface="Arial"/>
               </a:rPr>
-              <a:t>אין חיישן סביבתי מובנה בלוח -- זו כבר החלטת מוצר</a:t>
+              <a:t>ללוח אין חיישן סביבתי מובנה -- כך ש"איזה חיישן" משקף 3 מעולם לא היה פרט טכני, אלא החלטת מוצר אמיתית שמישהו היה חייב לקבל לפני שהקוד יכול היה להיות נכון.</a:t>
             </a:r>
           </a:p>
           <a:p>
@@ -6562,13 +6683,13 @@
               </a:spcAft>
             </a:pPr>
             <a:r>
-              <a:rPr sz="2200" b="0" i="0">
+              <a:rPr sz="2000" b="0" i="0">
                 <a:solidFill>
                   <a:srgbClr val="334155"/>
                 </a:solidFill>
                 <a:latin typeface="Arial"/>
               </a:rPr>
-              <a:t>פרט טכני מפתיע: פיני ה-I2C של המסך הם 17/18, לא ברירת המחדל של ESP32 (21/22)</a:t>
+              <a:t>פרט טכני מפתיע אחד שקל לטעות בו: על הלוח הספציפי הזה, פיני ה-I2C של המסך המובנה הם GPIO 17/18, לא פיני ה-I2C המקובלים של ESP32 (21/22) -- לטעות בזה גורם למסך להישאר ריק לגמרי בלי שום הודעת שגיאה.</a:t>
             </a:r>
           </a:p>
         </p:txBody>
@@ -6654,13 +6775,13 @@
               </a:spcAft>
             </a:pPr>
             <a:r>
-              <a:rPr sz="2400" b="1" i="0">
+              <a:rPr sz="2200" b="1" i="0">
                 <a:solidFill>
                   <a:srgbClr val="2563EB"/>
                 </a:solidFill>
                 <a:latin typeface="Arial"/>
               </a:rPr>
-              <a:t>המסר: הנחה משתמעת מול החלטה מפורשת</a:t>
+              <a:t>המסר של ההשוואה הזו: הנחה משתמעת מול החלטה מפורשת -- לא "קוד גרוע מול קוד טוב".</a:t>
             </a:r>
           </a:p>
           <a:p>
@@ -6670,13 +6791,13 @@
               </a:spcAft>
             </a:pPr>
             <a:r>
-              <a:rPr sz="2000" b="0" i="0">
+              <a:rPr sz="1900" b="0" i="0">
                 <a:solidFill>
                   <a:srgbClr val="334155"/>
                 </a:solidFill>
                 <a:latin typeface="Arial"/>
               </a:rPr>
-              <a:t>חיווט החומרה (I2C, Vext) נכון בשתי הגרסאות</a:t>
+              <a:t>כדי לשמור על ההשוואה הוגנת, חיווט החומרה (פיני I2C, רצף הפעלת Vext) נכון בשתי הגרסאות -- גם בגרסת הפרומפט-בלבד וגם בגרסה המונחית-מפרט; טעויות חיווט הן לא הסיפור כאן.</a:t>
             </a:r>
           </a:p>
           <a:p>
@@ -6686,13 +6807,13 @@
               </a:spcAft>
             </a:pPr>
             <a:r>
-              <a:rPr sz="2000" b="0" i="0">
+              <a:rPr sz="1900" b="0" i="0">
                 <a:solidFill>
                   <a:srgbClr val="334155"/>
                 </a:solidFill>
                 <a:latin typeface="Arial"/>
               </a:rPr>
-              <a:t>מה שחסר: איזה חיישן, מה הסף המדויק, האם צריך היסטרזיס</a:t>
+              <a:t>מה שבאמת שונה זה כל מה שהפרומפט המקורי מעולם לא פירט: איזה חיישן בדיוק להשתמש, מה הסף המספרי המדויק, והאם האזהרה צריכה רצועת סבילות (היסטרזיס) סביב הסף הזה.</a:t>
             </a:r>
           </a:p>
           <a:p>
@@ -6702,13 +6823,13 @@
               </a:spcAft>
             </a:pPr>
             <a:r>
-              <a:rPr sz="2000" b="0" i="1">
+              <a:rPr sz="1900" b="0" i="1">
                 <a:solidFill>
                   <a:srgbClr val="334155"/>
                 </a:solidFill>
                 <a:latin typeface="Arial"/>
               </a:rPr>
-              <a:t>דוגמה מרכזית: אין היסטרזיס -- לא "באג", תוצאה של דרישה שמעולם לא נוסחה</a:t>
+              <a:t>הדוגמה הכי ברורה: לגרסת הפרומפט-בלבד אין בכלל היסטרזיס. זה לא באג בתכנות -- הקוד עושה בדיוק מה שקריאה סבירה של הפרומפט מרמזת. זו התוצאה הישירה של דרישה שפשוט מעולם לא נוסחה.</a:t>
             </a:r>
           </a:p>
         </p:txBody>
@@ -6774,8 +6895,8 @@
         </p:nvSpPr>
         <p:spPr>
           <a:xfrm>
-            <a:off x="548640" y="1280160"/>
-            <a:ext cx="11094415" cy="4206240"/>
+            <a:off x="548640" y="1097280"/>
+            <a:ext cx="11094415" cy="1371600"/>
           </a:xfrm>
           <a:prstGeom prst="rect">
             <a:avLst/>
@@ -6794,13 +6915,13 @@
               </a:spcAft>
             </a:pPr>
             <a:r>
-              <a:rPr sz="2200" b="0" i="0">
+              <a:rPr sz="1900" b="0" i="0">
                 <a:solidFill>
                   <a:srgbClr val="334155"/>
                 </a:solidFill>
                 <a:latin typeface="Arial"/>
               </a:rPr>
-              <a:t>4 השאלות שנשאלו בפועל:</a:t>
+              <a:t>specify כותב מה המוצר אמור לעשות, בשפה פשוטה, בלי לגעת עדיין בקוד -- למעשה טיוטה ראשונה של spec.md.</a:t>
             </a:r>
           </a:p>
           <a:p>
@@ -6810,13 +6931,13 @@
               </a:spcAft>
             </a:pPr>
             <a:r>
-              <a:rPr sz="2200" b="0" i="0">
+              <a:rPr sz="1900" b="0" i="0">
                 <a:solidFill>
                   <a:srgbClr val="334155"/>
                 </a:solidFill>
                 <a:latin typeface="Arial"/>
               </a:rPr>
-              <a:t>קצב דגימה • גבולות סף מדויקים • debounce לתקלה • תוכן המסך בזמן תקלה</a:t>
+              <a:t>clarify לאחר מכן שואל את האדם שאלות ממוקדות בדיוק על הפערים שראינו בשקף 3, מקליט כל תשובה ישירות לתוך המפרט. למטה התמליל האמיתי:</a:t>
             </a:r>
           </a:p>
         </p:txBody>
@@ -6837,8 +6958,8 @@
         </p:blipFill>
         <p:spPr>
           <a:xfrm>
-            <a:off x="822960" y="2743200"/>
-            <a:ext cx="10515600" cy="3030967"/>
+            <a:off x="822960" y="2788920"/>
+            <a:ext cx="10058400" cy="2899186"/>
           </a:xfrm>
           <a:prstGeom prst="rect">
             <a:avLst/>
@@ -8383,13 +8504,13 @@
               </a:spcAft>
             </a:pPr>
             <a:r>
-              <a:rPr sz="2200" b="0" i="0">
+              <a:rPr sz="1800" b="0" i="1">
                 <a:solidFill>
                   <a:srgbClr val="334155"/>
                 </a:solidFill>
                 <a:latin typeface="Arial"/>
               </a:rPr>
-              <a:t>איזה חיישן?</a:t>
+              <a:t>סוכן קידוד עדיין חייב לענות על כל אחת מהשאלות האלה -- הוא פשוט עונה עליהן בשקט, בניחוש:</a:t>
             </a:r>
           </a:p>
           <a:p>
@@ -8399,13 +8520,13 @@
               </a:spcAft>
             </a:pPr>
             <a:r>
-              <a:rPr sz="2200" b="0" i="0">
+              <a:rPr sz="1900" b="0" i="0">
                 <a:solidFill>
                   <a:srgbClr val="334155"/>
                 </a:solidFill>
                 <a:latin typeface="Arial"/>
               </a:rPr>
-              <a:t>כל כמה זמן דוגמים?</a:t>
+              <a:t>איזה חיישן בפועל מחובר? (טמפרטורה בלבד? טמפרטורה + לחות? איזה צ'יפ?)</a:t>
             </a:r>
           </a:p>
           <a:p>
@@ -8415,13 +8536,13 @@
               </a:spcAft>
             </a:pPr>
             <a:r>
-              <a:rPr sz="2200" b="0" i="0">
+              <a:rPr sz="1900" b="0" i="0">
                 <a:solidFill>
                   <a:srgbClr val="334155"/>
                 </a:solidFill>
                 <a:latin typeface="Arial"/>
               </a:rPr>
-              <a:t>מה זה בדיוק "גבוה מדי"?</a:t>
+              <a:t>כל כמה זמן צריך לדגום את הערך -- פעם בשנייה? פעם בדקה?</a:t>
             </a:r>
           </a:p>
           <a:p>
@@ -8431,13 +8552,13 @@
               </a:spcAft>
             </a:pPr>
             <a:r>
-              <a:rPr sz="2200" b="0" i="0">
+              <a:rPr sz="1900" b="0" i="0">
                 <a:solidFill>
                   <a:srgbClr val="334155"/>
                 </a:solidFill>
                 <a:latin typeface="Arial"/>
               </a:rPr>
-              <a:t>מה קורה בדיוק בסף?</a:t>
+              <a:t>מה בדיוק נחשב "גבוה מדי" -- מה הסף המספרי המדויק?</a:t>
             </a:r>
           </a:p>
           <a:p>
@@ -8447,13 +8568,13 @@
               </a:spcAft>
             </a:pPr>
             <a:r>
-              <a:rPr sz="2200" b="0" i="0">
+              <a:rPr sz="1900" b="0" i="0">
                 <a:solidFill>
                   <a:srgbClr val="334155"/>
                 </a:solidFill>
                 <a:latin typeface="Arial"/>
               </a:rPr>
-              <a:t>מתי האזהרה נכבית?</a:t>
+              <a:t>מה קורה בדיוק בסביבת הסף -- האם האזהרה מהבהבת כשהערך מרפרף שם?</a:t>
             </a:r>
           </a:p>
           <a:p>
@@ -8463,13 +8584,13 @@
               </a:spcAft>
             </a:pPr>
             <a:r>
-              <a:rPr sz="2200" b="0" i="0">
+              <a:rPr sz="1900" b="0" i="0">
                 <a:solidFill>
                   <a:srgbClr val="334155"/>
                 </a:solidFill>
                 <a:latin typeface="Arial"/>
               </a:rPr>
-              <a:t>מה קורה כשהחיישן נכשל?</a:t>
+              <a:t>כשהאזהרה כבר מוצגת, באיזו נקודה בדיוק היא נכבית?</a:t>
             </a:r>
           </a:p>
           <a:p>
@@ -8479,13 +8600,13 @@
               </a:spcAft>
             </a:pPr>
             <a:r>
-              <a:rPr sz="2200" b="0" i="0">
+              <a:rPr sz="1900" b="0" i="0">
                 <a:solidFill>
                   <a:srgbClr val="334155"/>
                 </a:solidFill>
                 <a:latin typeface="Arial"/>
               </a:rPr>
-              <a:t>מה מוצג במסך בזמן תקלה?</a:t>
+              <a:t>מה צריך לקרות אם החיישן מפסיק להגיב או מחזיר ערך שגוי?</a:t>
             </a:r>
           </a:p>
           <a:p>
@@ -8495,13 +8616,29 @@
               </a:spcAft>
             </a:pPr>
             <a:r>
-              <a:rPr sz="2200" b="0" i="0">
+              <a:rPr sz="1900" b="0" i="0">
                 <a:solidFill>
                   <a:srgbClr val="334155"/>
                 </a:solidFill>
                 <a:latin typeface="Arial"/>
               </a:rPr>
-              <a:t>מה נכתב ל-Serial?</a:t>
+              <a:t>מה המסך אמור להציג בזמן שהתקלה הזו קורית?</a:t>
+            </a:r>
+          </a:p>
+          <a:p>
+            <a:pPr algn="r" rtl="1">
+              <a:spcAft>
+                <a:spcPts val="1200"/>
+              </a:spcAft>
+            </a:pPr>
+            <a:r>
+              <a:rPr sz="1900" b="0" i="0">
+                <a:solidFill>
+                  <a:srgbClr val="334155"/>
+                </a:solidFill>
+                <a:latin typeface="Arial"/>
+              </a:rPr>
+              <a:t>מה, אם בכלל, נכתב לקונסולת ה-Serial לצורך דיבוג?</a:t>
             </a:r>
           </a:p>
         </p:txBody>
@@ -9177,7 +9314,7 @@
                 </a:solidFill>
                 <a:latin typeface="Arial"/>
               </a:rPr>
-              <a:t>מה זה GitHub Spec Kit</a:t>
+              <a:t>מה זה GitHub Spec Kit -- ולמה הוא בכלל קיים?</a:t>
             </a:r>
           </a:p>
         </p:txBody>
@@ -9190,8 +9327,8 @@
         </p:nvSpPr>
         <p:spPr>
           <a:xfrm>
-            <a:off x="548640" y="1280160"/>
-            <a:ext cx="11094415" cy="4206240"/>
+            <a:off x="548640" y="1143000"/>
+            <a:ext cx="11094415" cy="4297680"/>
           </a:xfrm>
           <a:prstGeom prst="rect">
             <a:avLst/>
@@ -9210,13 +9347,13 @@
               </a:spcAft>
             </a:pPr>
             <a:r>
-              <a:rPr sz="2400" b="0" i="0">
+              <a:rPr sz="2000" b="1" i="0">
                 <a:solidFill>
                   <a:srgbClr val="334155"/>
                 </a:solidFill>
                 <a:latin typeface="Arial"/>
               </a:rPr>
-              <a:t>Spec Kit = כלי CLI (specify) + סט Skills/Commands לסוכן קידוד</a:t>
+              <a:t>זה כלי קוד פתוח שפרסמה GitHub עצמה (github.com/github/spec-kit) -- חינמי, לא מוצר שקונים.</a:t>
             </a:r>
           </a:p>
           <a:p>
@@ -9226,13 +9363,45 @@
               </a:spcAft>
             </a:pPr>
             <a:r>
-              <a:rPr sz="2400" b="0" i="0">
+              <a:rPr sz="2000" b="0" i="0">
                 <a:solidFill>
                   <a:srgbClr val="334155"/>
                 </a:solidFill>
                 <a:latin typeface="Arial"/>
               </a:rPr>
-              <a:t>לא כותב קוד בעצמו -- מבנה את *התהליך* שמוביל לכתיבת הקוד</a:t>
+              <a:t>בפועל, מדובר בשני דברים: כלי שורת-פקודה קטן בשם specify, ועוד סט של Skills/Commands (פקודות ה-/speckit-... שהצגנו) שהוא מתקין אצל סוכן הקידוד שלכם -- Claude Code, Codex, או אחרים.</a:t>
+            </a:r>
+          </a:p>
+          <a:p>
+            <a:pPr algn="r" rtl="1">
+              <a:spcAft>
+                <a:spcPts val="1200"/>
+              </a:spcAft>
+            </a:pPr>
+            <a:r>
+              <a:rPr sz="2000" b="0" i="0">
+                <a:solidFill>
+                  <a:srgbClr val="334155"/>
+                </a:solidFill>
+                <a:latin typeface="Arial"/>
+              </a:rPr>
+              <a:t>Spec Kit לא כותב את קוד האפליקציה בעצמו, והוא גם לא מודל AI. הוא מבנה את *התהליך* שאדם וסוכן AI עוברים יחד לפני ותוך כדי כתיבת הקוד: להסכים על כללים, לכתוב דרישות, לפתור אי-בהירות, לתכנן את הגישה הטכנית, לפרק לעבודה למשימות, לבדוק הכול לסתירות, ורק אז לממש.</a:t>
+            </a:r>
+          </a:p>
+          <a:p>
+            <a:pPr algn="r" rtl="1">
+              <a:spcAft>
+                <a:spcPts val="1200"/>
+              </a:spcAft>
+            </a:pPr>
+            <a:r>
+              <a:rPr sz="1800" b="0" i="0">
+                <a:solidFill>
+                  <a:srgbClr val="334155"/>
+                </a:solidFill>
+                <a:latin typeface="Arial"/>
+              </a:rPr>
+              <a:t>למה GitHub בנתה את זה: ככל שסוכני קידוד AI נהיו מהירים מספיק לייצר פיצ'רים שלמים תוך שניות, צוותים גילו שהקוד כבר כמעט אף פעם לא צוואר הבקבוק -- דרישות לא ברורות או לא כתובות היו. הדפוס הזה נקרא "פיתוח מונחה-מפרט" (spec-driven development), ו-Spec Kit הוא הכלים של GitHub בשבילו: דרך מעשית לשמור על המהירות של סוכן AI בלי לוותר על המשמעת של לדעת מה בדיוק בונים.</a:t>
             </a:r>
           </a:p>
         </p:txBody>
@@ -9245,8 +9414,8 @@
         </p:nvSpPr>
         <p:spPr>
           <a:xfrm>
-            <a:off x="731520" y="2926080"/>
-            <a:ext cx="10728655" cy="2560320"/>
+            <a:off x="731520" y="5532120"/>
+            <a:ext cx="10728655" cy="1005840"/>
           </a:xfrm>
           <a:prstGeom prst="rect">
             <a:avLst/>

</xml_diff>